<commit_message>
add things to ppt
</commit_message>
<xml_diff>
--- a/LB2/LB2.pptx
+++ b/LB2/LB2.pptx
@@ -108,6 +108,11 @@
       </a:defRPr>
     </a:lvl9pPr>
   </p:defaultTextStyle>
+  <p:extLst>
+    <p:ext uri="{EFAFB233-063F-42B5-8137-9DF3F51BA10A}">
+      <p15:sldGuideLst xmlns:p15="http://schemas.microsoft.com/office/powerpoint/2012/main"/>
+    </p:ext>
+  </p:extLst>
 </p:presentation>
 </file>
 
@@ -950,43 +955,6 @@
         </a:p>
       </dgm:t>
     </dgm:pt>
-    <dgm:pt modelId="{272D95CA-1B13-4AEB-861E-9FED919112C8}">
-      <dgm:prSet/>
-      <dgm:spPr/>
-      <dgm:t>
-        <a:bodyPr/>
-        <a:lstStyle/>
-        <a:p>
-          <a:r>
-            <a:rPr lang="de-CH"/>
-            <a:t>Herangehensweise</a:t>
-          </a:r>
-          <a:endParaRPr lang="en-US"/>
-        </a:p>
-      </dgm:t>
-    </dgm:pt>
-    <dgm:pt modelId="{FE4DE427-0357-49B4-A12B-19F609E36CB4}" type="parTrans" cxnId="{75CAA030-25BA-40F6-8557-8B05BAA648FD}">
-      <dgm:prSet/>
-      <dgm:spPr/>
-      <dgm:t>
-        <a:bodyPr/>
-        <a:lstStyle/>
-        <a:p>
-          <a:endParaRPr lang="en-US"/>
-        </a:p>
-      </dgm:t>
-    </dgm:pt>
-    <dgm:pt modelId="{63F71EEC-7B2F-4092-8C94-A7B74C81B0B6}" type="sibTrans" cxnId="{75CAA030-25BA-40F6-8557-8B05BAA648FD}">
-      <dgm:prSet/>
-      <dgm:spPr/>
-      <dgm:t>
-        <a:bodyPr/>
-        <a:lstStyle/>
-        <a:p>
-          <a:endParaRPr lang="en-US"/>
-        </a:p>
-      </dgm:t>
-    </dgm:pt>
     <dgm:pt modelId="{788DB37D-C91D-49EB-8952-E485C570E91A}">
       <dgm:prSet/>
       <dgm:spPr/>
@@ -1045,11 +1013,11 @@
       <dgm:spPr/>
     </dgm:pt>
     <dgm:pt modelId="{389B28DA-3106-407B-A127-742B15F41E97}" type="pres">
-      <dgm:prSet presAssocID="{11F79C86-314B-4E52-99E7-657B56D8F760}" presName="background" presStyleLbl="node0" presStyleIdx="0" presStyleCnt="4"/>
+      <dgm:prSet presAssocID="{11F79C86-314B-4E52-99E7-657B56D8F760}" presName="background" presStyleLbl="node0" presStyleIdx="0" presStyleCnt="3"/>
       <dgm:spPr/>
     </dgm:pt>
     <dgm:pt modelId="{11289389-6DEB-4599-B81F-3D1FD3FA3DF1}" type="pres">
-      <dgm:prSet presAssocID="{11F79C86-314B-4E52-99E7-657B56D8F760}" presName="text" presStyleLbl="fgAcc0" presStyleIdx="0" presStyleCnt="4">
+      <dgm:prSet presAssocID="{11F79C86-314B-4E52-99E7-657B56D8F760}" presName="text" presStyleLbl="fgAcc0" presStyleIdx="0" presStyleCnt="3">
         <dgm:presLayoutVars>
           <dgm:chPref val="3"/>
         </dgm:presLayoutVars>
@@ -1069,11 +1037,11 @@
       <dgm:spPr/>
     </dgm:pt>
     <dgm:pt modelId="{B84F92A2-A5E1-408F-A096-A9BF8C064E83}" type="pres">
-      <dgm:prSet presAssocID="{617C08E3-D070-444F-930F-EBAC0DAC7581}" presName="background" presStyleLbl="node0" presStyleIdx="1" presStyleCnt="4"/>
+      <dgm:prSet presAssocID="{617C08E3-D070-444F-930F-EBAC0DAC7581}" presName="background" presStyleLbl="node0" presStyleIdx="1" presStyleCnt="3"/>
       <dgm:spPr/>
     </dgm:pt>
     <dgm:pt modelId="{8AD53D65-22E6-47A4-9B65-9840F1DB434B}" type="pres">
-      <dgm:prSet presAssocID="{617C08E3-D070-444F-930F-EBAC0DAC7581}" presName="text" presStyleLbl="fgAcc0" presStyleIdx="1" presStyleCnt="4">
+      <dgm:prSet presAssocID="{617C08E3-D070-444F-930F-EBAC0DAC7581}" presName="text" presStyleLbl="fgAcc0" presStyleIdx="1" presStyleCnt="3">
         <dgm:presLayoutVars>
           <dgm:chPref val="3"/>
         </dgm:presLayoutVars>
@@ -1082,30 +1050,6 @@
     </dgm:pt>
     <dgm:pt modelId="{CD8BA619-1DC7-4583-8A6C-388C2AB275E7}" type="pres">
       <dgm:prSet presAssocID="{617C08E3-D070-444F-930F-EBAC0DAC7581}" presName="hierChild2" presStyleCnt="0"/>
-      <dgm:spPr/>
-    </dgm:pt>
-    <dgm:pt modelId="{8DB4C624-0A0E-462A-A98D-BA2122220BDD}" type="pres">
-      <dgm:prSet presAssocID="{272D95CA-1B13-4AEB-861E-9FED919112C8}" presName="hierRoot1" presStyleCnt="0"/>
-      <dgm:spPr/>
-    </dgm:pt>
-    <dgm:pt modelId="{9CCF5FA3-C6E2-44C5-895D-764785296366}" type="pres">
-      <dgm:prSet presAssocID="{272D95CA-1B13-4AEB-861E-9FED919112C8}" presName="composite" presStyleCnt="0"/>
-      <dgm:spPr/>
-    </dgm:pt>
-    <dgm:pt modelId="{6CE5B004-EDF3-40EB-AFD4-E97D77B518CD}" type="pres">
-      <dgm:prSet presAssocID="{272D95CA-1B13-4AEB-861E-9FED919112C8}" presName="background" presStyleLbl="node0" presStyleIdx="2" presStyleCnt="4"/>
-      <dgm:spPr/>
-    </dgm:pt>
-    <dgm:pt modelId="{FA112FF1-0334-4621-8E71-F56291530D1A}" type="pres">
-      <dgm:prSet presAssocID="{272D95CA-1B13-4AEB-861E-9FED919112C8}" presName="text" presStyleLbl="fgAcc0" presStyleIdx="2" presStyleCnt="4">
-        <dgm:presLayoutVars>
-          <dgm:chPref val="3"/>
-        </dgm:presLayoutVars>
-      </dgm:prSet>
-      <dgm:spPr/>
-    </dgm:pt>
-    <dgm:pt modelId="{0B73FB23-E67A-4E56-A6F4-E616B872D0C1}" type="pres">
-      <dgm:prSet presAssocID="{272D95CA-1B13-4AEB-861E-9FED919112C8}" presName="hierChild2" presStyleCnt="0"/>
       <dgm:spPr/>
     </dgm:pt>
     <dgm:pt modelId="{C38D1E99-8956-4CED-B15D-0F75145E37C4}" type="pres">
@@ -1117,11 +1061,11 @@
       <dgm:spPr/>
     </dgm:pt>
     <dgm:pt modelId="{AF12755E-B9C2-4948-983B-1C2322DD08F1}" type="pres">
-      <dgm:prSet presAssocID="{788DB37D-C91D-49EB-8952-E485C570E91A}" presName="background" presStyleLbl="node0" presStyleIdx="3" presStyleCnt="4"/>
+      <dgm:prSet presAssocID="{788DB37D-C91D-49EB-8952-E485C570E91A}" presName="background" presStyleLbl="node0" presStyleIdx="2" presStyleCnt="3"/>
       <dgm:spPr/>
     </dgm:pt>
     <dgm:pt modelId="{1AA9CB32-B361-4789-B5D3-3AE310257CA9}" type="pres">
-      <dgm:prSet presAssocID="{788DB37D-C91D-49EB-8952-E485C570E91A}" presName="text" presStyleLbl="fgAcc0" presStyleIdx="3" presStyleCnt="4">
+      <dgm:prSet presAssocID="{788DB37D-C91D-49EB-8952-E485C570E91A}" presName="text" presStyleLbl="fgAcc0" presStyleIdx="2" presStyleCnt="3">
         <dgm:presLayoutVars>
           <dgm:chPref val="3"/>
         </dgm:presLayoutVars>
@@ -1138,11 +1082,9 @@
     <dgm:cxn modelId="{6871CE1D-2B7B-4EF1-8F2E-EC6888EF7B90}" type="presOf" srcId="{788DB37D-C91D-49EB-8952-E485C570E91A}" destId="{1AA9CB32-B361-4789-B5D3-3AE310257CA9}" srcOrd="0" destOrd="0" presId="urn:microsoft.com/office/officeart/2005/8/layout/hierarchy1"/>
     <dgm:cxn modelId="{C7741A28-27A7-49DB-ABD6-DABAE9B1C829}" type="presOf" srcId="{11F79C86-314B-4E52-99E7-657B56D8F760}" destId="{11289389-6DEB-4599-B81F-3D1FD3FA3DF1}" srcOrd="0" destOrd="0" presId="urn:microsoft.com/office/officeart/2005/8/layout/hierarchy1"/>
     <dgm:cxn modelId="{A3F5392A-67DC-48E2-960A-8FDE9A3CF59A}" type="presOf" srcId="{617C08E3-D070-444F-930F-EBAC0DAC7581}" destId="{8AD53D65-22E6-47A4-9B65-9840F1DB434B}" srcOrd="0" destOrd="0" presId="urn:microsoft.com/office/officeart/2005/8/layout/hierarchy1"/>
-    <dgm:cxn modelId="{75CAA030-25BA-40F6-8557-8B05BAA648FD}" srcId="{1528C369-44D6-4BE6-9A3A-4A8608DBA0E0}" destId="{272D95CA-1B13-4AEB-861E-9FED919112C8}" srcOrd="2" destOrd="0" parTransId="{FE4DE427-0357-49B4-A12B-19F609E36CB4}" sibTransId="{63F71EEC-7B2F-4092-8C94-A7B74C81B0B6}"/>
     <dgm:cxn modelId="{7220506E-EBD8-4B44-BDF5-C85F92A2195E}" srcId="{1528C369-44D6-4BE6-9A3A-4A8608DBA0E0}" destId="{617C08E3-D070-444F-930F-EBAC0DAC7581}" srcOrd="1" destOrd="0" parTransId="{5A4881B4-947A-4BD2-B933-4C7DB176A3DF}" sibTransId="{0703D6EB-75BB-4EEC-B6F8-E6CDF6CFA009}"/>
     <dgm:cxn modelId="{76C76193-BAA6-413A-9864-86337D107125}" type="presOf" srcId="{1528C369-44D6-4BE6-9A3A-4A8608DBA0E0}" destId="{626BEB7E-E907-457C-AA7B-ACE4D2643C5A}" srcOrd="0" destOrd="0" presId="urn:microsoft.com/office/officeart/2005/8/layout/hierarchy1"/>
-    <dgm:cxn modelId="{774200BF-8779-4742-B842-FA078D427102}" type="presOf" srcId="{272D95CA-1B13-4AEB-861E-9FED919112C8}" destId="{FA112FF1-0334-4621-8E71-F56291530D1A}" srcOrd="0" destOrd="0" presId="urn:microsoft.com/office/officeart/2005/8/layout/hierarchy1"/>
-    <dgm:cxn modelId="{EF3C8BD0-B723-4FB8-8303-FBAAAE52B910}" srcId="{1528C369-44D6-4BE6-9A3A-4A8608DBA0E0}" destId="{788DB37D-C91D-49EB-8952-E485C570E91A}" srcOrd="3" destOrd="0" parTransId="{5DAE3A10-3677-4535-81D7-87D1EAE0EB74}" sibTransId="{1951943E-0038-4E10-BD7C-1EDCC04B16A0}"/>
+    <dgm:cxn modelId="{EF3C8BD0-B723-4FB8-8303-FBAAAE52B910}" srcId="{1528C369-44D6-4BE6-9A3A-4A8608DBA0E0}" destId="{788DB37D-C91D-49EB-8952-E485C570E91A}" srcOrd="2" destOrd="0" parTransId="{5DAE3A10-3677-4535-81D7-87D1EAE0EB74}" sibTransId="{1951943E-0038-4E10-BD7C-1EDCC04B16A0}"/>
     <dgm:cxn modelId="{94030068-16A2-4729-8181-2E790F03F5BB}" type="presParOf" srcId="{626BEB7E-E907-457C-AA7B-ACE4D2643C5A}" destId="{9DD7DAD9-2CA7-4276-A8DF-6CC128F94E15}" srcOrd="0" destOrd="0" presId="urn:microsoft.com/office/officeart/2005/8/layout/hierarchy1"/>
     <dgm:cxn modelId="{CB9DB440-0DCF-4250-9F3F-7D3672B17898}" type="presParOf" srcId="{9DD7DAD9-2CA7-4276-A8DF-6CC128F94E15}" destId="{9630F9AA-0008-4804-8F29-CB4C2E81CBC1}" srcOrd="0" destOrd="0" presId="urn:microsoft.com/office/officeart/2005/8/layout/hierarchy1"/>
     <dgm:cxn modelId="{711EACD6-7224-4ABF-AD13-08E1959E419F}" type="presParOf" srcId="{9630F9AA-0008-4804-8F29-CB4C2E81CBC1}" destId="{389B28DA-3106-407B-A127-742B15F41E97}" srcOrd="0" destOrd="0" presId="urn:microsoft.com/office/officeart/2005/8/layout/hierarchy1"/>
@@ -1153,12 +1095,7 @@
     <dgm:cxn modelId="{05876A65-2645-416E-9FB6-418F4095F3C8}" type="presParOf" srcId="{289E92C9-96F9-437C-BB46-839E1395CAB3}" destId="{B84F92A2-A5E1-408F-A096-A9BF8C064E83}" srcOrd="0" destOrd="0" presId="urn:microsoft.com/office/officeart/2005/8/layout/hierarchy1"/>
     <dgm:cxn modelId="{1873CC21-534D-4B06-B56E-BF771AB323BC}" type="presParOf" srcId="{289E92C9-96F9-437C-BB46-839E1395CAB3}" destId="{8AD53D65-22E6-47A4-9B65-9840F1DB434B}" srcOrd="1" destOrd="0" presId="urn:microsoft.com/office/officeart/2005/8/layout/hierarchy1"/>
     <dgm:cxn modelId="{9D8FE8BB-5D54-4198-9BA5-EC139F60520B}" type="presParOf" srcId="{46D9F92D-E195-43B1-AC69-10233AFECDAD}" destId="{CD8BA619-1DC7-4583-8A6C-388C2AB275E7}" srcOrd="1" destOrd="0" presId="urn:microsoft.com/office/officeart/2005/8/layout/hierarchy1"/>
-    <dgm:cxn modelId="{EC6F2CCB-C788-4A1C-960F-C54BA0457DAF}" type="presParOf" srcId="{626BEB7E-E907-457C-AA7B-ACE4D2643C5A}" destId="{8DB4C624-0A0E-462A-A98D-BA2122220BDD}" srcOrd="2" destOrd="0" presId="urn:microsoft.com/office/officeart/2005/8/layout/hierarchy1"/>
-    <dgm:cxn modelId="{8D1648C1-B071-4E24-BF9F-A4F967300AF4}" type="presParOf" srcId="{8DB4C624-0A0E-462A-A98D-BA2122220BDD}" destId="{9CCF5FA3-C6E2-44C5-895D-764785296366}" srcOrd="0" destOrd="0" presId="urn:microsoft.com/office/officeart/2005/8/layout/hierarchy1"/>
-    <dgm:cxn modelId="{84413F4A-98FC-4099-ADEF-F834DE4E4C1D}" type="presParOf" srcId="{9CCF5FA3-C6E2-44C5-895D-764785296366}" destId="{6CE5B004-EDF3-40EB-AFD4-E97D77B518CD}" srcOrd="0" destOrd="0" presId="urn:microsoft.com/office/officeart/2005/8/layout/hierarchy1"/>
-    <dgm:cxn modelId="{26D8E76C-6DF6-4060-82B8-D1EB895F922E}" type="presParOf" srcId="{9CCF5FA3-C6E2-44C5-895D-764785296366}" destId="{FA112FF1-0334-4621-8E71-F56291530D1A}" srcOrd="1" destOrd="0" presId="urn:microsoft.com/office/officeart/2005/8/layout/hierarchy1"/>
-    <dgm:cxn modelId="{8C5C0AAE-981D-4A0F-AB02-1B3E9297CB80}" type="presParOf" srcId="{8DB4C624-0A0E-462A-A98D-BA2122220BDD}" destId="{0B73FB23-E67A-4E56-A6F4-E616B872D0C1}" srcOrd="1" destOrd="0" presId="urn:microsoft.com/office/officeart/2005/8/layout/hierarchy1"/>
-    <dgm:cxn modelId="{4634DE8D-0669-4E8A-9A66-D2536DB99DA3}" type="presParOf" srcId="{626BEB7E-E907-457C-AA7B-ACE4D2643C5A}" destId="{C38D1E99-8956-4CED-B15D-0F75145E37C4}" srcOrd="3" destOrd="0" presId="urn:microsoft.com/office/officeart/2005/8/layout/hierarchy1"/>
+    <dgm:cxn modelId="{4634DE8D-0669-4E8A-9A66-D2536DB99DA3}" type="presParOf" srcId="{626BEB7E-E907-457C-AA7B-ACE4D2643C5A}" destId="{C38D1E99-8956-4CED-B15D-0F75145E37C4}" srcOrd="2" destOrd="0" presId="urn:microsoft.com/office/officeart/2005/8/layout/hierarchy1"/>
     <dgm:cxn modelId="{82DCBC83-823B-476F-B7C3-8FCE624D1B8E}" type="presParOf" srcId="{C38D1E99-8956-4CED-B15D-0F75145E37C4}" destId="{EADA2BAF-7CA7-4E8C-8F15-BB3318EB46C3}" srcOrd="0" destOrd="0" presId="urn:microsoft.com/office/officeart/2005/8/layout/hierarchy1"/>
     <dgm:cxn modelId="{72C5A3D6-1371-4AD7-BDE6-85D2C8B9893D}" type="presParOf" srcId="{EADA2BAF-7CA7-4E8C-8F15-BB3318EB46C3}" destId="{AF12755E-B9C2-4948-983B-1C2322DD08F1}" srcOrd="0" destOrd="0" presId="urn:microsoft.com/office/officeart/2005/8/layout/hierarchy1"/>
     <dgm:cxn modelId="{128705AA-0E92-483F-9BF6-58F114DB09C7}" type="presParOf" srcId="{EADA2BAF-7CA7-4E8C-8F15-BB3318EB46C3}" destId="{1AA9CB32-B361-4789-B5D3-3AE310257CA9}" srcOrd="1" destOrd="0" presId="urn:microsoft.com/office/officeart/2005/8/layout/hierarchy1"/>
@@ -1189,8 +1126,8 @@
       </dsp:nvSpPr>
       <dsp:spPr>
         <a:xfrm>
-          <a:off x="3201" y="998291"/>
-          <a:ext cx="2285879" cy="1451533"/>
+          <a:off x="0" y="706671"/>
+          <a:ext cx="3073451" cy="1951641"/>
         </a:xfrm>
         <a:prstGeom prst="roundRect">
           <a:avLst>
@@ -1241,8 +1178,8 @@
       </dsp:nvSpPr>
       <dsp:spPr>
         <a:xfrm>
-          <a:off x="257188" y="1239579"/>
-          <a:ext cx="2285879" cy="1451533"/>
+          <a:off x="341494" y="1031091"/>
+          <a:ext cx="3073451" cy="1951641"/>
         </a:xfrm>
         <a:prstGeom prst="roundRect">
           <a:avLst>
@@ -1285,12 +1222,12 @@
         <a:fontRef idx="minor"/>
       </dsp:style>
       <dsp:txBody>
-        <a:bodyPr spcFirstLastPara="0" vert="horz" wrap="square" lIns="72390" tIns="72390" rIns="72390" bIns="72390" numCol="1" spcCol="1270" anchor="ctr" anchorCtr="0">
+        <a:bodyPr spcFirstLastPara="0" vert="horz" wrap="square" lIns="95250" tIns="95250" rIns="95250" bIns="95250" numCol="1" spcCol="1270" anchor="ctr" anchorCtr="0">
           <a:noAutofit/>
         </a:bodyPr>
         <a:lstStyle/>
         <a:p>
-          <a:pPr marL="0" lvl="0" indent="0" algn="ctr" defTabSz="844550">
+          <a:pPr marL="0" lvl="0" indent="0" algn="ctr" defTabSz="1111250">
             <a:lnSpc>
               <a:spcPct val="90000"/>
             </a:lnSpc>
@@ -1303,15 +1240,15 @@
             <a:buNone/>
           </a:pPr>
           <a:r>
-            <a:rPr lang="de-CH" sz="1900" kern="1200"/>
+            <a:rPr lang="de-CH" sz="2500" kern="1200"/>
             <a:t>Das Projekt</a:t>
           </a:r>
-          <a:endParaRPr lang="en-US" sz="1900" kern="1200"/>
+          <a:endParaRPr lang="en-US" sz="2500" kern="1200"/>
         </a:p>
       </dsp:txBody>
       <dsp:txXfrm>
-        <a:off x="299702" y="1282093"/>
-        <a:ext cx="2200851" cy="1366505"/>
+        <a:off x="398656" y="1088253"/>
+        <a:ext cx="2959127" cy="1837317"/>
       </dsp:txXfrm>
     </dsp:sp>
     <dsp:sp modelId="{B84F92A2-A5E1-408F-A096-A9BF8C064E83}">
@@ -1321,8 +1258,8 @@
       </dsp:nvSpPr>
       <dsp:spPr>
         <a:xfrm>
-          <a:off x="2797054" y="998291"/>
-          <a:ext cx="2285879" cy="1451533"/>
+          <a:off x="3756441" y="706671"/>
+          <a:ext cx="3073451" cy="1951641"/>
         </a:xfrm>
         <a:prstGeom prst="roundRect">
           <a:avLst>
@@ -1373,8 +1310,8 @@
       </dsp:nvSpPr>
       <dsp:spPr>
         <a:xfrm>
-          <a:off x="3051041" y="1239579"/>
-          <a:ext cx="2285879" cy="1451533"/>
+          <a:off x="4097935" y="1031091"/>
+          <a:ext cx="3073451" cy="1951641"/>
         </a:xfrm>
         <a:prstGeom prst="roundRect">
           <a:avLst>
@@ -1417,12 +1354,12 @@
         <a:fontRef idx="minor"/>
       </dsp:style>
       <dsp:txBody>
-        <a:bodyPr spcFirstLastPara="0" vert="horz" wrap="square" lIns="72390" tIns="72390" rIns="72390" bIns="72390" numCol="1" spcCol="1270" anchor="ctr" anchorCtr="0">
+        <a:bodyPr spcFirstLastPara="0" vert="horz" wrap="square" lIns="95250" tIns="95250" rIns="95250" bIns="95250" numCol="1" spcCol="1270" anchor="ctr" anchorCtr="0">
           <a:noAutofit/>
         </a:bodyPr>
         <a:lstStyle/>
         <a:p>
-          <a:pPr marL="0" lvl="0" indent="0" algn="ctr" defTabSz="844550">
+          <a:pPr marL="0" lvl="0" indent="0" algn="ctr" defTabSz="1111250">
             <a:lnSpc>
               <a:spcPct val="90000"/>
             </a:lnSpc>
@@ -1435,147 +1372,15 @@
             <a:buNone/>
           </a:pPr>
           <a:r>
-            <a:rPr lang="de-CH" sz="1900" kern="1200"/>
+            <a:rPr lang="de-CH" sz="2500" kern="1200"/>
             <a:t>Produkt</a:t>
           </a:r>
-          <a:endParaRPr lang="en-US" sz="1900" kern="1200"/>
+          <a:endParaRPr lang="en-US" sz="2500" kern="1200"/>
         </a:p>
       </dsp:txBody>
       <dsp:txXfrm>
-        <a:off x="3093555" y="1282093"/>
-        <a:ext cx="2200851" cy="1366505"/>
-      </dsp:txXfrm>
-    </dsp:sp>
-    <dsp:sp modelId="{6CE5B004-EDF3-40EB-AFD4-E97D77B518CD}">
-      <dsp:nvSpPr>
-        <dsp:cNvPr id="0" name=""/>
-        <dsp:cNvSpPr/>
-      </dsp:nvSpPr>
-      <dsp:spPr>
-        <a:xfrm>
-          <a:off x="5590907" y="998291"/>
-          <a:ext cx="2285879" cy="1451533"/>
-        </a:xfrm>
-        <a:prstGeom prst="roundRect">
-          <a:avLst>
-            <a:gd name="adj" fmla="val 10000"/>
-          </a:avLst>
-        </a:prstGeom>
-        <a:solidFill>
-          <a:schemeClr val="dk2">
-            <a:hueOff val="0"/>
-            <a:satOff val="0"/>
-            <a:lumOff val="0"/>
-            <a:alphaOff val="0"/>
-          </a:schemeClr>
-        </a:solidFill>
-        <a:ln w="19050" cap="flat" cmpd="sng" algn="ctr">
-          <a:solidFill>
-            <a:schemeClr val="lt2">
-              <a:hueOff val="0"/>
-              <a:satOff val="0"/>
-              <a:lumOff val="0"/>
-              <a:alphaOff val="0"/>
-            </a:schemeClr>
-          </a:solidFill>
-          <a:prstDash val="solid"/>
-          <a:miter lim="800000"/>
-        </a:ln>
-        <a:effectLst/>
-      </dsp:spPr>
-      <dsp:style>
-        <a:lnRef idx="2">
-          <a:scrgbClr r="0" g="0" b="0"/>
-        </a:lnRef>
-        <a:fillRef idx="1">
-          <a:scrgbClr r="0" g="0" b="0"/>
-        </a:fillRef>
-        <a:effectRef idx="0">
-          <a:scrgbClr r="0" g="0" b="0"/>
-        </a:effectRef>
-        <a:fontRef idx="minor">
-          <a:schemeClr val="lt1"/>
-        </a:fontRef>
-      </dsp:style>
-    </dsp:sp>
-    <dsp:sp modelId="{FA112FF1-0334-4621-8E71-F56291530D1A}">
-      <dsp:nvSpPr>
-        <dsp:cNvPr id="0" name=""/>
-        <dsp:cNvSpPr/>
-      </dsp:nvSpPr>
-      <dsp:spPr>
-        <a:xfrm>
-          <a:off x="5844894" y="1239579"/>
-          <a:ext cx="2285879" cy="1451533"/>
-        </a:xfrm>
-        <a:prstGeom prst="roundRect">
-          <a:avLst>
-            <a:gd name="adj" fmla="val 10000"/>
-          </a:avLst>
-        </a:prstGeom>
-        <a:solidFill>
-          <a:schemeClr val="lt2">
-            <a:alpha val="90000"/>
-            <a:hueOff val="0"/>
-            <a:satOff val="0"/>
-            <a:lumOff val="0"/>
-            <a:alphaOff val="0"/>
-          </a:schemeClr>
-        </a:solidFill>
-        <a:ln w="19050" cap="flat" cmpd="sng" algn="ctr">
-          <a:solidFill>
-            <a:schemeClr val="dk2">
-              <a:hueOff val="0"/>
-              <a:satOff val="0"/>
-              <a:lumOff val="0"/>
-              <a:alphaOff val="0"/>
-            </a:schemeClr>
-          </a:solidFill>
-          <a:prstDash val="solid"/>
-          <a:miter lim="800000"/>
-        </a:ln>
-        <a:effectLst/>
-      </dsp:spPr>
-      <dsp:style>
-        <a:lnRef idx="2">
-          <a:scrgbClr r="0" g="0" b="0"/>
-        </a:lnRef>
-        <a:fillRef idx="1">
-          <a:scrgbClr r="0" g="0" b="0"/>
-        </a:fillRef>
-        <a:effectRef idx="0">
-          <a:scrgbClr r="0" g="0" b="0"/>
-        </a:effectRef>
-        <a:fontRef idx="minor"/>
-      </dsp:style>
-      <dsp:txBody>
-        <a:bodyPr spcFirstLastPara="0" vert="horz" wrap="square" lIns="72390" tIns="72390" rIns="72390" bIns="72390" numCol="1" spcCol="1270" anchor="ctr" anchorCtr="0">
-          <a:noAutofit/>
-        </a:bodyPr>
-        <a:lstStyle/>
-        <a:p>
-          <a:pPr marL="0" lvl="0" indent="0" algn="ctr" defTabSz="844550">
-            <a:lnSpc>
-              <a:spcPct val="90000"/>
-            </a:lnSpc>
-            <a:spcBef>
-              <a:spcPct val="0"/>
-            </a:spcBef>
-            <a:spcAft>
-              <a:spcPct val="35000"/>
-            </a:spcAft>
-            <a:buNone/>
-          </a:pPr>
-          <a:r>
-            <a:rPr lang="de-CH" sz="1900" kern="1200"/>
-            <a:t>Herangehensweise</a:t>
-          </a:r>
-          <a:endParaRPr lang="en-US" sz="1900" kern="1200"/>
-        </a:p>
-      </dsp:txBody>
-      <dsp:txXfrm>
-        <a:off x="5887408" y="1282093"/>
-        <a:ext cx="2200851" cy="1366505"/>
+        <a:off x="4155097" y="1088253"/>
+        <a:ext cx="2959127" cy="1837317"/>
       </dsp:txXfrm>
     </dsp:sp>
     <dsp:sp modelId="{AF12755E-B9C2-4948-983B-1C2322DD08F1}">
@@ -1585,8 +1390,8 @@
       </dsp:nvSpPr>
       <dsp:spPr>
         <a:xfrm>
-          <a:off x="8384760" y="998291"/>
-          <a:ext cx="2285879" cy="1451533"/>
+          <a:off x="7512882" y="706671"/>
+          <a:ext cx="3073451" cy="1951641"/>
         </a:xfrm>
         <a:prstGeom prst="roundRect">
           <a:avLst>
@@ -1637,8 +1442,8 @@
       </dsp:nvSpPr>
       <dsp:spPr>
         <a:xfrm>
-          <a:off x="8638747" y="1239579"/>
-          <a:ext cx="2285879" cy="1451533"/>
+          <a:off x="7854377" y="1031091"/>
+          <a:ext cx="3073451" cy="1951641"/>
         </a:xfrm>
         <a:prstGeom prst="roundRect">
           <a:avLst>
@@ -1681,12 +1486,12 @@
         <a:fontRef idx="minor"/>
       </dsp:style>
       <dsp:txBody>
-        <a:bodyPr spcFirstLastPara="0" vert="horz" wrap="square" lIns="72390" tIns="72390" rIns="72390" bIns="72390" numCol="1" spcCol="1270" anchor="ctr" anchorCtr="0">
+        <a:bodyPr spcFirstLastPara="0" vert="horz" wrap="square" lIns="95250" tIns="95250" rIns="95250" bIns="95250" numCol="1" spcCol="1270" anchor="ctr" anchorCtr="0">
           <a:noAutofit/>
         </a:bodyPr>
         <a:lstStyle/>
         <a:p>
-          <a:pPr marL="0" lvl="0" indent="0" algn="ctr" defTabSz="844550">
+          <a:pPr marL="0" lvl="0" indent="0" algn="ctr" defTabSz="1111250">
             <a:lnSpc>
               <a:spcPct val="90000"/>
             </a:lnSpc>
@@ -1699,15 +1504,15 @@
             <a:buNone/>
           </a:pPr>
           <a:r>
-            <a:rPr lang="de-CH" sz="1900" kern="1200"/>
+            <a:rPr lang="de-CH" sz="2500" kern="1200"/>
             <a:t>Herausforderungen</a:t>
           </a:r>
-          <a:endParaRPr lang="en-US" sz="1900" kern="1200"/>
+          <a:endParaRPr lang="en-US" sz="2500" kern="1200"/>
         </a:p>
       </dsp:txBody>
       <dsp:txXfrm>
-        <a:off x="8681261" y="1282093"/>
-        <a:ext cx="2200851" cy="1366505"/>
+        <a:off x="7911539" y="1088253"/>
+        <a:ext cx="2959127" cy="1837317"/>
       </dsp:txXfrm>
     </dsp:sp>
   </dsp:spTree>
@@ -3460,7 +3265,7 @@
           <a:p>
             <a:fld id="{90C06C34-4A22-4938-AADD-8EC846606CB8}" type="datetimeFigureOut">
               <a:rPr lang="de-CH" smtClean="0"/>
-              <a:t>29.06.2026</a:t>
+              <a:t>06.07.2026</a:t>
             </a:fld>
             <a:endParaRPr lang="de-CH"/>
           </a:p>
@@ -3660,7 +3465,7 @@
           <a:p>
             <a:fld id="{90C06C34-4A22-4938-AADD-8EC846606CB8}" type="datetimeFigureOut">
               <a:rPr lang="de-CH" smtClean="0"/>
-              <a:t>29.06.2026</a:t>
+              <a:t>06.07.2026</a:t>
             </a:fld>
             <a:endParaRPr lang="de-CH"/>
           </a:p>
@@ -3870,7 +3675,7 @@
           <a:p>
             <a:fld id="{90C06C34-4A22-4938-AADD-8EC846606CB8}" type="datetimeFigureOut">
               <a:rPr lang="de-CH" smtClean="0"/>
-              <a:t>29.06.2026</a:t>
+              <a:t>06.07.2026</a:t>
             </a:fld>
             <a:endParaRPr lang="de-CH"/>
           </a:p>
@@ -4070,7 +3875,7 @@
           <a:p>
             <a:fld id="{90C06C34-4A22-4938-AADD-8EC846606CB8}" type="datetimeFigureOut">
               <a:rPr lang="de-CH" smtClean="0"/>
-              <a:t>29.06.2026</a:t>
+              <a:t>06.07.2026</a:t>
             </a:fld>
             <a:endParaRPr lang="de-CH"/>
           </a:p>
@@ -4346,7 +4151,7 @@
           <a:p>
             <a:fld id="{90C06C34-4A22-4938-AADD-8EC846606CB8}" type="datetimeFigureOut">
               <a:rPr lang="de-CH" smtClean="0"/>
-              <a:t>29.06.2026</a:t>
+              <a:t>06.07.2026</a:t>
             </a:fld>
             <a:endParaRPr lang="de-CH"/>
           </a:p>
@@ -4614,7 +4419,7 @@
           <a:p>
             <a:fld id="{90C06C34-4A22-4938-AADD-8EC846606CB8}" type="datetimeFigureOut">
               <a:rPr lang="de-CH" smtClean="0"/>
-              <a:t>29.06.2026</a:t>
+              <a:t>06.07.2026</a:t>
             </a:fld>
             <a:endParaRPr lang="de-CH"/>
           </a:p>
@@ -5029,7 +4834,7 @@
           <a:p>
             <a:fld id="{90C06C34-4A22-4938-AADD-8EC846606CB8}" type="datetimeFigureOut">
               <a:rPr lang="de-CH" smtClean="0"/>
-              <a:t>29.06.2026</a:t>
+              <a:t>06.07.2026</a:t>
             </a:fld>
             <a:endParaRPr lang="de-CH"/>
           </a:p>
@@ -5171,7 +4976,7 @@
           <a:p>
             <a:fld id="{90C06C34-4A22-4938-AADD-8EC846606CB8}" type="datetimeFigureOut">
               <a:rPr lang="de-CH" smtClean="0"/>
-              <a:t>29.06.2026</a:t>
+              <a:t>06.07.2026</a:t>
             </a:fld>
             <a:endParaRPr lang="de-CH"/>
           </a:p>
@@ -5284,7 +5089,7 @@
           <a:p>
             <a:fld id="{90C06C34-4A22-4938-AADD-8EC846606CB8}" type="datetimeFigureOut">
               <a:rPr lang="de-CH" smtClean="0"/>
-              <a:t>29.06.2026</a:t>
+              <a:t>06.07.2026</a:t>
             </a:fld>
             <a:endParaRPr lang="de-CH"/>
           </a:p>
@@ -5597,7 +5402,7 @@
           <a:p>
             <a:fld id="{90C06C34-4A22-4938-AADD-8EC846606CB8}" type="datetimeFigureOut">
               <a:rPr lang="de-CH" smtClean="0"/>
-              <a:t>29.06.2026</a:t>
+              <a:t>06.07.2026</a:t>
             </a:fld>
             <a:endParaRPr lang="de-CH"/>
           </a:p>
@@ -5886,7 +5691,7 @@
           <a:p>
             <a:fld id="{90C06C34-4A22-4938-AADD-8EC846606CB8}" type="datetimeFigureOut">
               <a:rPr lang="de-CH" smtClean="0"/>
-              <a:t>29.06.2026</a:t>
+              <a:t>06.07.2026</a:t>
             </a:fld>
             <a:endParaRPr lang="de-CH"/>
           </a:p>
@@ -6129,7 +5934,7 @@
           <a:p>
             <a:fld id="{90C06C34-4A22-4938-AADD-8EC846606CB8}" type="datetimeFigureOut">
               <a:rPr lang="de-CH" smtClean="0"/>
-              <a:t>29.06.2026</a:t>
+              <a:t>06.07.2026</a:t>
             </a:fld>
             <a:endParaRPr lang="de-CH"/>
           </a:p>
@@ -7263,7 +7068,7 @@
             <p:ph idx="1"/>
             <p:extLst>
               <p:ext uri="{D42A27DB-BD31-4B8C-83A1-F6EECF244321}">
-                <p14:modId xmlns:p14="http://schemas.microsoft.com/office/powerpoint/2010/main" val="2887197179"/>
+                <p14:modId xmlns:p14="http://schemas.microsoft.com/office/powerpoint/2010/main" val="745525363"/>
               </p:ext>
             </p:extLst>
           </p:nvPr>
@@ -8278,7 +8083,7 @@
           <a:lstStyle/>
           <a:p>
             <a:r>
-              <a:rPr lang="de-CH" sz="2000"/>
+              <a:rPr lang="de-CH" sz="2000" dirty="0"/>
               <a:t>https://lorissuperstar.github.io/m293/index.html</a:t>
             </a:r>
           </a:p>
@@ -8858,8 +8663,14 @@
           <a:lstStyle/>
           <a:p>
             <a:r>
-              <a:rPr lang="de-CH" sz="2000"/>
-              <a:t>Pages (Mit Ai debugt)</a:t>
+              <a:rPr lang="de-CH" sz="2000" dirty="0"/>
+              <a:t>Pages</a:t>
+            </a:r>
+          </a:p>
+          <a:p>
+            <a:r>
+              <a:rPr lang="de-CH" sz="2000" dirty="0"/>
+              <a:t>Keine Tokens mehr</a:t>
             </a:r>
           </a:p>
         </p:txBody>

</xml_diff>